<commit_message>
feat: aktualisiere bearbeitbare Karten und füge neue PDF-Datei für englische Karten hinzu
</commit_message>
<xml_diff>
--- a/assets/cards/editable/cards_de.pptx
+++ b/assets/cards/editable/cards_de.pptx
@@ -13171,7 +13171,7 @@
                 <a:ea typeface="Open Sans Condensed" pitchFamily="2" charset="0"/>
                 <a:cs typeface="Open Sans Condensed" pitchFamily="2" charset="0"/>
               </a:rPr>
-              <a:t>BEWEGUNGEN</a:t>
+              <a:t>AUFZEICHNUNGEN</a:t>
             </a:r>
             <a:r>
               <a:rPr lang="de-DE" sz="1000" b="1" dirty="0">
@@ -13969,7 +13969,7 @@
                 <a:ea typeface="Open Sans Condensed" pitchFamily="2" charset="0"/>
                 <a:cs typeface="Open Sans Condensed" pitchFamily="2" charset="0"/>
               </a:rPr>
-              <a:t>GRENZEN </a:t>
+              <a:t>GESICHTER UND GEISTER </a:t>
             </a:r>
             <a:endParaRPr sz="1000" b="1" dirty="0">
               <a:solidFill>

</xml_diff>